<commit_message>
Deleted the .ps1 for the presentation.
</commit_message>
<xml_diff>
--- a/ScriptHub-Presentacion.pptx
+++ b/ScriptHub-Presentacion.pptx
@@ -134,7 +134,7 @@
           <p:cNvPr id="2" name="Title 1">
             <a:extLst>
               <a:ext uri="{FF2B5EF4-FFF2-40B4-BE49-F238E27FC236}">
-                <a16:creationId xmlns:a16="http://schemas.microsoft.com/office/drawing/2014/main" id="{4F31EC9F-5986-8743-C8CD-08BD179464B4}"/>
+                <a16:creationId xmlns:a16="http://schemas.microsoft.com/office/drawing/2014/main" id="{CF46E3D6-4E14-F79A-3295-CD271F658C00}"/>
               </a:ext>
             </a:extLst>
           </p:cNvPr>
@@ -171,7 +171,7 @@
           <p:cNvPr id="3" name="Subtitle 2">
             <a:extLst>
               <a:ext uri="{FF2B5EF4-FFF2-40B4-BE49-F238E27FC236}">
-                <a16:creationId xmlns:a16="http://schemas.microsoft.com/office/drawing/2014/main" id="{6242122D-0204-6132-F864-EB9D2D8B3845}"/>
+                <a16:creationId xmlns:a16="http://schemas.microsoft.com/office/drawing/2014/main" id="{498742DD-9EB1-DEAA-B24A-D259CE8D15E2}"/>
               </a:ext>
             </a:extLst>
           </p:cNvPr>
@@ -241,7 +241,7 @@
           <p:cNvPr id="4" name="Date Placeholder 3">
             <a:extLst>
               <a:ext uri="{FF2B5EF4-FFF2-40B4-BE49-F238E27FC236}">
-                <a16:creationId xmlns:a16="http://schemas.microsoft.com/office/drawing/2014/main" id="{3656F046-9051-BE0D-845D-9F1161447A7A}"/>
+                <a16:creationId xmlns:a16="http://schemas.microsoft.com/office/drawing/2014/main" id="{B30BE710-2BEF-353A-018A-78E1BB4D59E8}"/>
               </a:ext>
             </a:extLst>
           </p:cNvPr>
@@ -257,9 +257,9 @@
           <a:bodyPr/>
           <a:lstStyle/>
           <a:p>
-            <a:fld id="{D6CBD7AF-9F59-4387-953D-7AF4223CD7B2}" type="datetimeFigureOut">
+            <a:fld id="{424CA8A1-6869-4F6F-94B9-4672574CFC1C}" type="datetimeFigureOut">
               <a:rPr lang="en-US" smtClean="0"/>
-              <a:t>9/17/2026</a:t>
+              <a:t>9/19/2026</a:t>
             </a:fld>
             <a:endParaRPr lang="en-US"/>
           </a:p>
@@ -270,7 +270,7 @@
           <p:cNvPr id="5" name="Footer Placeholder 4">
             <a:extLst>
               <a:ext uri="{FF2B5EF4-FFF2-40B4-BE49-F238E27FC236}">
-                <a16:creationId xmlns:a16="http://schemas.microsoft.com/office/drawing/2014/main" id="{D6DCD774-CB57-0648-2843-734B4E911FD9}"/>
+                <a16:creationId xmlns:a16="http://schemas.microsoft.com/office/drawing/2014/main" id="{DB8A06CF-F0E1-9141-A921-019A2020F925}"/>
               </a:ext>
             </a:extLst>
           </p:cNvPr>
@@ -295,7 +295,7 @@
           <p:cNvPr id="6" name="Slide Number Placeholder 5">
             <a:extLst>
               <a:ext uri="{FF2B5EF4-FFF2-40B4-BE49-F238E27FC236}">
-                <a16:creationId xmlns:a16="http://schemas.microsoft.com/office/drawing/2014/main" id="{C54A37D9-E96C-6F1C-19F0-CC5586F28775}"/>
+                <a16:creationId xmlns:a16="http://schemas.microsoft.com/office/drawing/2014/main" id="{15BB260E-04A7-41A3-7D8D-C46A68DDF1CA}"/>
               </a:ext>
             </a:extLst>
           </p:cNvPr>
@@ -311,7 +311,7 @@
           <a:bodyPr/>
           <a:lstStyle/>
           <a:p>
-            <a:fld id="{9D915052-6BD4-4097-932F-7C78C6FCA82D}" type="slidenum">
+            <a:fld id="{88F39F1B-68C9-456A-BB80-0F545E82F8A5}" type="slidenum">
               <a:rPr lang="en-US" smtClean="0"/>
               <a:t>‹#›</a:t>
             </a:fld>
@@ -322,7 +322,7 @@
     </p:spTree>
     <p:extLst>
       <p:ext uri="{BB962C8B-B14F-4D97-AF65-F5344CB8AC3E}">
-        <p14:creationId xmlns:p14="http://schemas.microsoft.com/office/powerpoint/2010/main" val="541926936"/>
+        <p14:creationId xmlns:p14="http://schemas.microsoft.com/office/powerpoint/2010/main" val="4165876929"/>
       </p:ext>
     </p:extLst>
   </p:cSld>
@@ -354,7 +354,7 @@
           <p:cNvPr id="2" name="Title 1">
             <a:extLst>
               <a:ext uri="{FF2B5EF4-FFF2-40B4-BE49-F238E27FC236}">
-                <a16:creationId xmlns:a16="http://schemas.microsoft.com/office/drawing/2014/main" id="{C88722A1-63B3-7111-3566-8FDFBAD81402}"/>
+                <a16:creationId xmlns:a16="http://schemas.microsoft.com/office/drawing/2014/main" id="{1167B377-6E1C-F0F6-A061-184FB7EAC2C5}"/>
               </a:ext>
             </a:extLst>
           </p:cNvPr>
@@ -382,7 +382,7 @@
           <p:cNvPr id="3" name="Vertical Text Placeholder 2">
             <a:extLst>
               <a:ext uri="{FF2B5EF4-FFF2-40B4-BE49-F238E27FC236}">
-                <a16:creationId xmlns:a16="http://schemas.microsoft.com/office/drawing/2014/main" id="{0BBE3DFB-9BB7-FCEC-419C-A5A231ADF424}"/>
+                <a16:creationId xmlns:a16="http://schemas.microsoft.com/office/drawing/2014/main" id="{C24F2790-4EEE-58DE-7D29-FC7A80D193FD}"/>
               </a:ext>
             </a:extLst>
           </p:cNvPr>
@@ -439,7 +439,7 @@
           <p:cNvPr id="4" name="Date Placeholder 3">
             <a:extLst>
               <a:ext uri="{FF2B5EF4-FFF2-40B4-BE49-F238E27FC236}">
-                <a16:creationId xmlns:a16="http://schemas.microsoft.com/office/drawing/2014/main" id="{4ACFD0CD-473E-07C0-E95C-4EAFBF5844BF}"/>
+                <a16:creationId xmlns:a16="http://schemas.microsoft.com/office/drawing/2014/main" id="{0780FABC-1474-BE3B-C26D-6436709E0786}"/>
               </a:ext>
             </a:extLst>
           </p:cNvPr>
@@ -455,9 +455,9 @@
           <a:bodyPr/>
           <a:lstStyle/>
           <a:p>
-            <a:fld id="{D6CBD7AF-9F59-4387-953D-7AF4223CD7B2}" type="datetimeFigureOut">
+            <a:fld id="{424CA8A1-6869-4F6F-94B9-4672574CFC1C}" type="datetimeFigureOut">
               <a:rPr lang="en-US" smtClean="0"/>
-              <a:t>9/17/2026</a:t>
+              <a:t>9/19/2026</a:t>
             </a:fld>
             <a:endParaRPr lang="en-US"/>
           </a:p>
@@ -468,7 +468,7 @@
           <p:cNvPr id="5" name="Footer Placeholder 4">
             <a:extLst>
               <a:ext uri="{FF2B5EF4-FFF2-40B4-BE49-F238E27FC236}">
-                <a16:creationId xmlns:a16="http://schemas.microsoft.com/office/drawing/2014/main" id="{7D6D412B-FE5A-EFC4-D91A-4F7B64D3B1F3}"/>
+                <a16:creationId xmlns:a16="http://schemas.microsoft.com/office/drawing/2014/main" id="{B9D44717-934F-0E29-30FB-372C0C13467D}"/>
               </a:ext>
             </a:extLst>
           </p:cNvPr>
@@ -493,7 +493,7 @@
           <p:cNvPr id="6" name="Slide Number Placeholder 5">
             <a:extLst>
               <a:ext uri="{FF2B5EF4-FFF2-40B4-BE49-F238E27FC236}">
-                <a16:creationId xmlns:a16="http://schemas.microsoft.com/office/drawing/2014/main" id="{84D56FDD-BAE3-B89E-3D24-FF48433842F5}"/>
+                <a16:creationId xmlns:a16="http://schemas.microsoft.com/office/drawing/2014/main" id="{4B84F3E9-D5FB-B99C-B998-C455A954B453}"/>
               </a:ext>
             </a:extLst>
           </p:cNvPr>
@@ -509,7 +509,7 @@
           <a:bodyPr/>
           <a:lstStyle/>
           <a:p>
-            <a:fld id="{9D915052-6BD4-4097-932F-7C78C6FCA82D}" type="slidenum">
+            <a:fld id="{88F39F1B-68C9-456A-BB80-0F545E82F8A5}" type="slidenum">
               <a:rPr lang="en-US" smtClean="0"/>
               <a:t>‹#›</a:t>
             </a:fld>
@@ -520,7 +520,7 @@
     </p:spTree>
     <p:extLst>
       <p:ext uri="{BB962C8B-B14F-4D97-AF65-F5344CB8AC3E}">
-        <p14:creationId xmlns:p14="http://schemas.microsoft.com/office/powerpoint/2010/main" val="1015627867"/>
+        <p14:creationId xmlns:p14="http://schemas.microsoft.com/office/powerpoint/2010/main" val="1325432970"/>
       </p:ext>
     </p:extLst>
   </p:cSld>
@@ -552,7 +552,7 @@
           <p:cNvPr id="2" name="Vertical Title 1">
             <a:extLst>
               <a:ext uri="{FF2B5EF4-FFF2-40B4-BE49-F238E27FC236}">
-                <a16:creationId xmlns:a16="http://schemas.microsoft.com/office/drawing/2014/main" id="{5B9947C9-C7EE-BC98-1234-49D1903E46F4}"/>
+                <a16:creationId xmlns:a16="http://schemas.microsoft.com/office/drawing/2014/main" id="{2617C664-4E5B-AA55-0612-CD4F071DB11C}"/>
               </a:ext>
             </a:extLst>
           </p:cNvPr>
@@ -585,7 +585,7 @@
           <p:cNvPr id="3" name="Vertical Text Placeholder 2">
             <a:extLst>
               <a:ext uri="{FF2B5EF4-FFF2-40B4-BE49-F238E27FC236}">
-                <a16:creationId xmlns:a16="http://schemas.microsoft.com/office/drawing/2014/main" id="{DF20B403-19EA-EFCF-C468-2984ABF5B236}"/>
+                <a16:creationId xmlns:a16="http://schemas.microsoft.com/office/drawing/2014/main" id="{22066F3C-266E-4392-DCC1-86FD8864E540}"/>
               </a:ext>
             </a:extLst>
           </p:cNvPr>
@@ -647,7 +647,7 @@
           <p:cNvPr id="4" name="Date Placeholder 3">
             <a:extLst>
               <a:ext uri="{FF2B5EF4-FFF2-40B4-BE49-F238E27FC236}">
-                <a16:creationId xmlns:a16="http://schemas.microsoft.com/office/drawing/2014/main" id="{666BD105-0107-1819-D39D-3D78049DB971}"/>
+                <a16:creationId xmlns:a16="http://schemas.microsoft.com/office/drawing/2014/main" id="{8F5FEBF6-5E7A-2855-A54B-8DF2513ECD6C}"/>
               </a:ext>
             </a:extLst>
           </p:cNvPr>
@@ -663,9 +663,9 @@
           <a:bodyPr/>
           <a:lstStyle/>
           <a:p>
-            <a:fld id="{D6CBD7AF-9F59-4387-953D-7AF4223CD7B2}" type="datetimeFigureOut">
+            <a:fld id="{424CA8A1-6869-4F6F-94B9-4672574CFC1C}" type="datetimeFigureOut">
               <a:rPr lang="en-US" smtClean="0"/>
-              <a:t>9/17/2026</a:t>
+              <a:t>9/19/2026</a:t>
             </a:fld>
             <a:endParaRPr lang="en-US"/>
           </a:p>
@@ -676,7 +676,7 @@
           <p:cNvPr id="5" name="Footer Placeholder 4">
             <a:extLst>
               <a:ext uri="{FF2B5EF4-FFF2-40B4-BE49-F238E27FC236}">
-                <a16:creationId xmlns:a16="http://schemas.microsoft.com/office/drawing/2014/main" id="{44B7A8F4-C1E2-7C1B-017E-138A4CEA9491}"/>
+                <a16:creationId xmlns:a16="http://schemas.microsoft.com/office/drawing/2014/main" id="{FED15FEF-A161-BE16-8CE4-423DA89EDA5B}"/>
               </a:ext>
             </a:extLst>
           </p:cNvPr>
@@ -701,7 +701,7 @@
           <p:cNvPr id="6" name="Slide Number Placeholder 5">
             <a:extLst>
               <a:ext uri="{FF2B5EF4-FFF2-40B4-BE49-F238E27FC236}">
-                <a16:creationId xmlns:a16="http://schemas.microsoft.com/office/drawing/2014/main" id="{E44AAEFD-8229-BF60-EED9-2A0B0D1F11AE}"/>
+                <a16:creationId xmlns:a16="http://schemas.microsoft.com/office/drawing/2014/main" id="{4F549BBA-D525-EB7D-9AE0-7A96C0A4E31D}"/>
               </a:ext>
             </a:extLst>
           </p:cNvPr>
@@ -717,7 +717,7 @@
           <a:bodyPr/>
           <a:lstStyle/>
           <a:p>
-            <a:fld id="{9D915052-6BD4-4097-932F-7C78C6FCA82D}" type="slidenum">
+            <a:fld id="{88F39F1B-68C9-456A-BB80-0F545E82F8A5}" type="slidenum">
               <a:rPr lang="en-US" smtClean="0"/>
               <a:t>‹#›</a:t>
             </a:fld>
@@ -728,7 +728,7 @@
     </p:spTree>
     <p:extLst>
       <p:ext uri="{BB962C8B-B14F-4D97-AF65-F5344CB8AC3E}">
-        <p14:creationId xmlns:p14="http://schemas.microsoft.com/office/powerpoint/2010/main" val="1613753881"/>
+        <p14:creationId xmlns:p14="http://schemas.microsoft.com/office/powerpoint/2010/main" val="3100113860"/>
       </p:ext>
     </p:extLst>
   </p:cSld>
@@ -760,7 +760,7 @@
           <p:cNvPr id="2" name="Title 1">
             <a:extLst>
               <a:ext uri="{FF2B5EF4-FFF2-40B4-BE49-F238E27FC236}">
-                <a16:creationId xmlns:a16="http://schemas.microsoft.com/office/drawing/2014/main" id="{BBAF1897-7299-D21A-6934-4AF1E3716F30}"/>
+                <a16:creationId xmlns:a16="http://schemas.microsoft.com/office/drawing/2014/main" id="{B06DF206-954C-316A-E0BD-0C5603628547}"/>
               </a:ext>
             </a:extLst>
           </p:cNvPr>
@@ -788,7 +788,7 @@
           <p:cNvPr id="3" name="Text Placeholder 2">
             <a:extLst>
               <a:ext uri="{FF2B5EF4-FFF2-40B4-BE49-F238E27FC236}">
-                <a16:creationId xmlns:a16="http://schemas.microsoft.com/office/drawing/2014/main" id="{F98A3543-9975-FE81-4AB3-2F30FB391ACD}"/>
+                <a16:creationId xmlns:a16="http://schemas.microsoft.com/office/drawing/2014/main" id="{7C5E5C32-481F-B98D-6EA9-793867E70F2C}"/>
               </a:ext>
             </a:extLst>
           </p:cNvPr>
@@ -845,7 +845,7 @@
           <p:cNvPr id="4" name="Date Placeholder 3">
             <a:extLst>
               <a:ext uri="{FF2B5EF4-FFF2-40B4-BE49-F238E27FC236}">
-                <a16:creationId xmlns:a16="http://schemas.microsoft.com/office/drawing/2014/main" id="{BE500BC4-CDAC-8DC3-0219-C316CBEC8800}"/>
+                <a16:creationId xmlns:a16="http://schemas.microsoft.com/office/drawing/2014/main" id="{BE4B98EF-B61D-7776-841F-CC44041AD421}"/>
               </a:ext>
             </a:extLst>
           </p:cNvPr>
@@ -861,9 +861,9 @@
           <a:bodyPr/>
           <a:lstStyle/>
           <a:p>
-            <a:fld id="{D6CBD7AF-9F59-4387-953D-7AF4223CD7B2}" type="datetimeFigureOut">
+            <a:fld id="{424CA8A1-6869-4F6F-94B9-4672574CFC1C}" type="datetimeFigureOut">
               <a:rPr lang="en-US" smtClean="0"/>
-              <a:t>9/17/2026</a:t>
+              <a:t>9/19/2026</a:t>
             </a:fld>
             <a:endParaRPr lang="en-US"/>
           </a:p>
@@ -874,7 +874,7 @@
           <p:cNvPr id="5" name="Footer Placeholder 4">
             <a:extLst>
               <a:ext uri="{FF2B5EF4-FFF2-40B4-BE49-F238E27FC236}">
-                <a16:creationId xmlns:a16="http://schemas.microsoft.com/office/drawing/2014/main" id="{E2478B7B-8AA6-1263-628A-4936F75818F7}"/>
+                <a16:creationId xmlns:a16="http://schemas.microsoft.com/office/drawing/2014/main" id="{53397012-D275-7C95-6A9B-DFF662998DBA}"/>
               </a:ext>
             </a:extLst>
           </p:cNvPr>
@@ -899,7 +899,7 @@
           <p:cNvPr id="6" name="Slide Number Placeholder 5">
             <a:extLst>
               <a:ext uri="{FF2B5EF4-FFF2-40B4-BE49-F238E27FC236}">
-                <a16:creationId xmlns:a16="http://schemas.microsoft.com/office/drawing/2014/main" id="{30EBF455-BAC8-1A39-83ED-8B362E48DB2A}"/>
+                <a16:creationId xmlns:a16="http://schemas.microsoft.com/office/drawing/2014/main" id="{63C6FD87-D7A0-BCC3-0C70-2472072180F9}"/>
               </a:ext>
             </a:extLst>
           </p:cNvPr>
@@ -915,7 +915,7 @@
           <a:bodyPr/>
           <a:lstStyle/>
           <a:p>
-            <a:fld id="{9D915052-6BD4-4097-932F-7C78C6FCA82D}" type="slidenum">
+            <a:fld id="{88F39F1B-68C9-456A-BB80-0F545E82F8A5}" type="slidenum">
               <a:rPr lang="en-US" smtClean="0"/>
               <a:t>‹#›</a:t>
             </a:fld>
@@ -926,7 +926,7 @@
     </p:spTree>
     <p:extLst>
       <p:ext uri="{BB962C8B-B14F-4D97-AF65-F5344CB8AC3E}">
-        <p14:creationId xmlns:p14="http://schemas.microsoft.com/office/powerpoint/2010/main" val="2237111654"/>
+        <p14:creationId xmlns:p14="http://schemas.microsoft.com/office/powerpoint/2010/main" val="323895974"/>
       </p:ext>
     </p:extLst>
   </p:cSld>
@@ -958,7 +958,7 @@
           <p:cNvPr id="2" name="Title 1">
             <a:extLst>
               <a:ext uri="{FF2B5EF4-FFF2-40B4-BE49-F238E27FC236}">
-                <a16:creationId xmlns:a16="http://schemas.microsoft.com/office/drawing/2014/main" id="{AFC5FA10-CD48-7BE5-B96B-44D15AA547D8}"/>
+                <a16:creationId xmlns:a16="http://schemas.microsoft.com/office/drawing/2014/main" id="{749286B1-8963-DE45-B912-81484084064C}"/>
               </a:ext>
             </a:extLst>
           </p:cNvPr>
@@ -986,7 +986,7 @@
           <p:cNvPr id="3" name="Content Placeholder 2">
             <a:extLst>
               <a:ext uri="{FF2B5EF4-FFF2-40B4-BE49-F238E27FC236}">
-                <a16:creationId xmlns:a16="http://schemas.microsoft.com/office/drawing/2014/main" id="{D3517F84-CAC6-A5F3-F00F-0D35A04368F0}"/>
+                <a16:creationId xmlns:a16="http://schemas.microsoft.com/office/drawing/2014/main" id="{1C9FEB49-2C76-A37F-30E5-0C92AC3B2A1B}"/>
               </a:ext>
             </a:extLst>
           </p:cNvPr>
@@ -1043,7 +1043,7 @@
           <p:cNvPr id="4" name="Date Placeholder 3">
             <a:extLst>
               <a:ext uri="{FF2B5EF4-FFF2-40B4-BE49-F238E27FC236}">
-                <a16:creationId xmlns:a16="http://schemas.microsoft.com/office/drawing/2014/main" id="{BAB5726B-B3F0-D0F2-B3E1-E7FD2D6BAADD}"/>
+                <a16:creationId xmlns:a16="http://schemas.microsoft.com/office/drawing/2014/main" id="{11F7C2A6-5BEF-94C0-F9BC-830A76AFA683}"/>
               </a:ext>
             </a:extLst>
           </p:cNvPr>
@@ -1059,9 +1059,9 @@
           <a:bodyPr/>
           <a:lstStyle/>
           <a:p>
-            <a:fld id="{D6CBD7AF-9F59-4387-953D-7AF4223CD7B2}" type="datetimeFigureOut">
+            <a:fld id="{424CA8A1-6869-4F6F-94B9-4672574CFC1C}" type="datetimeFigureOut">
               <a:rPr lang="en-US" smtClean="0"/>
-              <a:t>9/17/2026</a:t>
+              <a:t>9/19/2026</a:t>
             </a:fld>
             <a:endParaRPr lang="en-US"/>
           </a:p>
@@ -1072,7 +1072,7 @@
           <p:cNvPr id="5" name="Footer Placeholder 4">
             <a:extLst>
               <a:ext uri="{FF2B5EF4-FFF2-40B4-BE49-F238E27FC236}">
-                <a16:creationId xmlns:a16="http://schemas.microsoft.com/office/drawing/2014/main" id="{0EBADB42-D38B-B691-4B63-E9E427BD8E8F}"/>
+                <a16:creationId xmlns:a16="http://schemas.microsoft.com/office/drawing/2014/main" id="{E742A3A4-4BDD-F0A6-5770-4A931F09C399}"/>
               </a:ext>
             </a:extLst>
           </p:cNvPr>
@@ -1097,7 +1097,7 @@
           <p:cNvPr id="6" name="Slide Number Placeholder 5">
             <a:extLst>
               <a:ext uri="{FF2B5EF4-FFF2-40B4-BE49-F238E27FC236}">
-                <a16:creationId xmlns:a16="http://schemas.microsoft.com/office/drawing/2014/main" id="{0D7AF96B-6FD6-415C-0A17-638F9ECED099}"/>
+                <a16:creationId xmlns:a16="http://schemas.microsoft.com/office/drawing/2014/main" id="{0C14E813-8012-4E56-9BF0-B2A8F282BB71}"/>
               </a:ext>
             </a:extLst>
           </p:cNvPr>
@@ -1113,7 +1113,7 @@
           <a:bodyPr/>
           <a:lstStyle/>
           <a:p>
-            <a:fld id="{9D915052-6BD4-4097-932F-7C78C6FCA82D}" type="slidenum">
+            <a:fld id="{88F39F1B-68C9-456A-BB80-0F545E82F8A5}" type="slidenum">
               <a:rPr lang="en-US" smtClean="0"/>
               <a:t>‹#›</a:t>
             </a:fld>
@@ -1124,7 +1124,7 @@
     </p:spTree>
     <p:extLst>
       <p:ext uri="{BB962C8B-B14F-4D97-AF65-F5344CB8AC3E}">
-        <p14:creationId xmlns:p14="http://schemas.microsoft.com/office/powerpoint/2010/main" val="3725383304"/>
+        <p14:creationId xmlns:p14="http://schemas.microsoft.com/office/powerpoint/2010/main" val="3408144760"/>
       </p:ext>
     </p:extLst>
   </p:cSld>
@@ -1156,7 +1156,7 @@
           <p:cNvPr id="2" name="Title 1">
             <a:extLst>
               <a:ext uri="{FF2B5EF4-FFF2-40B4-BE49-F238E27FC236}">
-                <a16:creationId xmlns:a16="http://schemas.microsoft.com/office/drawing/2014/main" id="{EDD5579F-BC59-5D00-BE4E-4969F8A4D4B8}"/>
+                <a16:creationId xmlns:a16="http://schemas.microsoft.com/office/drawing/2014/main" id="{B5EB8FA2-6D72-2202-F9DB-CE1D36654E9E}"/>
               </a:ext>
             </a:extLst>
           </p:cNvPr>
@@ -1193,7 +1193,7 @@
           <p:cNvPr id="3" name="Text Placeholder 2">
             <a:extLst>
               <a:ext uri="{FF2B5EF4-FFF2-40B4-BE49-F238E27FC236}">
-                <a16:creationId xmlns:a16="http://schemas.microsoft.com/office/drawing/2014/main" id="{6D9A3452-3269-66A0-212D-EFCD5D7DC6D0}"/>
+                <a16:creationId xmlns:a16="http://schemas.microsoft.com/office/drawing/2014/main" id="{8EF739C6-5602-DDFB-93A6-0B9AAD78450B}"/>
               </a:ext>
             </a:extLst>
           </p:cNvPr>
@@ -1318,7 +1318,7 @@
           <p:cNvPr id="4" name="Date Placeholder 3">
             <a:extLst>
               <a:ext uri="{FF2B5EF4-FFF2-40B4-BE49-F238E27FC236}">
-                <a16:creationId xmlns:a16="http://schemas.microsoft.com/office/drawing/2014/main" id="{3AE58ED6-5427-CF94-556C-81D4C0647255}"/>
+                <a16:creationId xmlns:a16="http://schemas.microsoft.com/office/drawing/2014/main" id="{B1129548-DB3D-E922-FAA7-BBAF56EEF818}"/>
               </a:ext>
             </a:extLst>
           </p:cNvPr>
@@ -1334,9 +1334,9 @@
           <a:bodyPr/>
           <a:lstStyle/>
           <a:p>
-            <a:fld id="{D6CBD7AF-9F59-4387-953D-7AF4223CD7B2}" type="datetimeFigureOut">
+            <a:fld id="{424CA8A1-6869-4F6F-94B9-4672574CFC1C}" type="datetimeFigureOut">
               <a:rPr lang="en-US" smtClean="0"/>
-              <a:t>9/17/2026</a:t>
+              <a:t>9/19/2026</a:t>
             </a:fld>
             <a:endParaRPr lang="en-US"/>
           </a:p>
@@ -1347,7 +1347,7 @@
           <p:cNvPr id="5" name="Footer Placeholder 4">
             <a:extLst>
               <a:ext uri="{FF2B5EF4-FFF2-40B4-BE49-F238E27FC236}">
-                <a16:creationId xmlns:a16="http://schemas.microsoft.com/office/drawing/2014/main" id="{D589B0DD-697E-658D-A935-A5F50E87D3C9}"/>
+                <a16:creationId xmlns:a16="http://schemas.microsoft.com/office/drawing/2014/main" id="{43384EEA-C7C0-53B4-35F9-579200741D14}"/>
               </a:ext>
             </a:extLst>
           </p:cNvPr>
@@ -1372,7 +1372,7 @@
           <p:cNvPr id="6" name="Slide Number Placeholder 5">
             <a:extLst>
               <a:ext uri="{FF2B5EF4-FFF2-40B4-BE49-F238E27FC236}">
-                <a16:creationId xmlns:a16="http://schemas.microsoft.com/office/drawing/2014/main" id="{D0097565-FA3F-6F3E-E385-E68B9C3AC802}"/>
+                <a16:creationId xmlns:a16="http://schemas.microsoft.com/office/drawing/2014/main" id="{446AEDE8-D0B8-97C4-8CCB-324FB97CB59D}"/>
               </a:ext>
             </a:extLst>
           </p:cNvPr>
@@ -1388,7 +1388,7 @@
           <a:bodyPr/>
           <a:lstStyle/>
           <a:p>
-            <a:fld id="{9D915052-6BD4-4097-932F-7C78C6FCA82D}" type="slidenum">
+            <a:fld id="{88F39F1B-68C9-456A-BB80-0F545E82F8A5}" type="slidenum">
               <a:rPr lang="en-US" smtClean="0"/>
               <a:t>‹#›</a:t>
             </a:fld>
@@ -1399,7 +1399,7 @@
     </p:spTree>
     <p:extLst>
       <p:ext uri="{BB962C8B-B14F-4D97-AF65-F5344CB8AC3E}">
-        <p14:creationId xmlns:p14="http://schemas.microsoft.com/office/powerpoint/2010/main" val="3168301198"/>
+        <p14:creationId xmlns:p14="http://schemas.microsoft.com/office/powerpoint/2010/main" val="994189022"/>
       </p:ext>
     </p:extLst>
   </p:cSld>
@@ -1431,7 +1431,7 @@
           <p:cNvPr id="2" name="Title 1">
             <a:extLst>
               <a:ext uri="{FF2B5EF4-FFF2-40B4-BE49-F238E27FC236}">
-                <a16:creationId xmlns:a16="http://schemas.microsoft.com/office/drawing/2014/main" id="{5F1F036F-7E87-0033-F003-586087E0F6B9}"/>
+                <a16:creationId xmlns:a16="http://schemas.microsoft.com/office/drawing/2014/main" id="{00FA5D6E-29E4-CC68-D863-F018D6BF6D99}"/>
               </a:ext>
             </a:extLst>
           </p:cNvPr>
@@ -1459,7 +1459,7 @@
           <p:cNvPr id="3" name="Content Placeholder 2">
             <a:extLst>
               <a:ext uri="{FF2B5EF4-FFF2-40B4-BE49-F238E27FC236}">
-                <a16:creationId xmlns:a16="http://schemas.microsoft.com/office/drawing/2014/main" id="{E7F85805-5B02-863C-7CF1-A96965E03580}"/>
+                <a16:creationId xmlns:a16="http://schemas.microsoft.com/office/drawing/2014/main" id="{362A7A1B-4A6A-970C-69D4-F43B4B049DB5}"/>
               </a:ext>
             </a:extLst>
           </p:cNvPr>
@@ -1521,7 +1521,7 @@
           <p:cNvPr id="4" name="Content Placeholder 3">
             <a:extLst>
               <a:ext uri="{FF2B5EF4-FFF2-40B4-BE49-F238E27FC236}">
-                <a16:creationId xmlns:a16="http://schemas.microsoft.com/office/drawing/2014/main" id="{3FCAAF25-AD8E-E15F-FB79-6C26CA253D2C}"/>
+                <a16:creationId xmlns:a16="http://schemas.microsoft.com/office/drawing/2014/main" id="{56C9EEE3-098A-EFBB-3A3F-3B3B8886DE8C}"/>
               </a:ext>
             </a:extLst>
           </p:cNvPr>
@@ -1583,7 +1583,7 @@
           <p:cNvPr id="5" name="Date Placeholder 4">
             <a:extLst>
               <a:ext uri="{FF2B5EF4-FFF2-40B4-BE49-F238E27FC236}">
-                <a16:creationId xmlns:a16="http://schemas.microsoft.com/office/drawing/2014/main" id="{41881769-58E4-D4DF-9387-853E053CF69C}"/>
+                <a16:creationId xmlns:a16="http://schemas.microsoft.com/office/drawing/2014/main" id="{B225845C-317B-4F9E-1CF7-C3B87E0D8283}"/>
               </a:ext>
             </a:extLst>
           </p:cNvPr>
@@ -1599,9 +1599,9 @@
           <a:bodyPr/>
           <a:lstStyle/>
           <a:p>
-            <a:fld id="{D6CBD7AF-9F59-4387-953D-7AF4223CD7B2}" type="datetimeFigureOut">
+            <a:fld id="{424CA8A1-6869-4F6F-94B9-4672574CFC1C}" type="datetimeFigureOut">
               <a:rPr lang="en-US" smtClean="0"/>
-              <a:t>9/17/2026</a:t>
+              <a:t>9/19/2026</a:t>
             </a:fld>
             <a:endParaRPr lang="en-US"/>
           </a:p>
@@ -1612,7 +1612,7 @@
           <p:cNvPr id="6" name="Footer Placeholder 5">
             <a:extLst>
               <a:ext uri="{FF2B5EF4-FFF2-40B4-BE49-F238E27FC236}">
-                <a16:creationId xmlns:a16="http://schemas.microsoft.com/office/drawing/2014/main" id="{02978FA9-DEE9-ACE0-678E-5818E10978C4}"/>
+                <a16:creationId xmlns:a16="http://schemas.microsoft.com/office/drawing/2014/main" id="{8766C506-955D-970C-04B4-645AC42CAE4C}"/>
               </a:ext>
             </a:extLst>
           </p:cNvPr>
@@ -1637,7 +1637,7 @@
           <p:cNvPr id="7" name="Slide Number Placeholder 6">
             <a:extLst>
               <a:ext uri="{FF2B5EF4-FFF2-40B4-BE49-F238E27FC236}">
-                <a16:creationId xmlns:a16="http://schemas.microsoft.com/office/drawing/2014/main" id="{995E20C2-EA1B-8033-4CDE-34BEE3F50CD7}"/>
+                <a16:creationId xmlns:a16="http://schemas.microsoft.com/office/drawing/2014/main" id="{9A4A76F1-5BD0-D523-A4F8-90A14BEF3B25}"/>
               </a:ext>
             </a:extLst>
           </p:cNvPr>
@@ -1653,7 +1653,7 @@
           <a:bodyPr/>
           <a:lstStyle/>
           <a:p>
-            <a:fld id="{9D915052-6BD4-4097-932F-7C78C6FCA82D}" type="slidenum">
+            <a:fld id="{88F39F1B-68C9-456A-BB80-0F545E82F8A5}" type="slidenum">
               <a:rPr lang="en-US" smtClean="0"/>
               <a:t>‹#›</a:t>
             </a:fld>
@@ -1664,7 +1664,7 @@
     </p:spTree>
     <p:extLst>
       <p:ext uri="{BB962C8B-B14F-4D97-AF65-F5344CB8AC3E}">
-        <p14:creationId xmlns:p14="http://schemas.microsoft.com/office/powerpoint/2010/main" val="1294288775"/>
+        <p14:creationId xmlns:p14="http://schemas.microsoft.com/office/powerpoint/2010/main" val="1051118770"/>
       </p:ext>
     </p:extLst>
   </p:cSld>
@@ -1696,7 +1696,7 @@
           <p:cNvPr id="2" name="Title 1">
             <a:extLst>
               <a:ext uri="{FF2B5EF4-FFF2-40B4-BE49-F238E27FC236}">
-                <a16:creationId xmlns:a16="http://schemas.microsoft.com/office/drawing/2014/main" id="{185294EA-2DD3-F5B4-2421-85A1BAF2EF9B}"/>
+                <a16:creationId xmlns:a16="http://schemas.microsoft.com/office/drawing/2014/main" id="{41A85A54-BD8E-96F0-50A1-6FEC1382FD60}"/>
               </a:ext>
             </a:extLst>
           </p:cNvPr>
@@ -1729,7 +1729,7 @@
           <p:cNvPr id="3" name="Text Placeholder 2">
             <a:extLst>
               <a:ext uri="{FF2B5EF4-FFF2-40B4-BE49-F238E27FC236}">
-                <a16:creationId xmlns:a16="http://schemas.microsoft.com/office/drawing/2014/main" id="{392694B4-F4A8-3C54-0C2A-90E24895F0EC}"/>
+                <a16:creationId xmlns:a16="http://schemas.microsoft.com/office/drawing/2014/main" id="{4EB0E7F0-0837-BE13-CC40-F98B7F8C3B54}"/>
               </a:ext>
             </a:extLst>
           </p:cNvPr>
@@ -1800,7 +1800,7 @@
           <p:cNvPr id="4" name="Content Placeholder 3">
             <a:extLst>
               <a:ext uri="{FF2B5EF4-FFF2-40B4-BE49-F238E27FC236}">
-                <a16:creationId xmlns:a16="http://schemas.microsoft.com/office/drawing/2014/main" id="{93A44E5C-3F6A-A6E7-1738-990D2C343ED6}"/>
+                <a16:creationId xmlns:a16="http://schemas.microsoft.com/office/drawing/2014/main" id="{AC7C245F-F8BA-216A-30BB-D30794887FF1}"/>
               </a:ext>
             </a:extLst>
           </p:cNvPr>
@@ -1862,7 +1862,7 @@
           <p:cNvPr id="5" name="Text Placeholder 4">
             <a:extLst>
               <a:ext uri="{FF2B5EF4-FFF2-40B4-BE49-F238E27FC236}">
-                <a16:creationId xmlns:a16="http://schemas.microsoft.com/office/drawing/2014/main" id="{E91FC838-132C-43B0-6C07-F398F889E465}"/>
+                <a16:creationId xmlns:a16="http://schemas.microsoft.com/office/drawing/2014/main" id="{36521717-078D-25A8-92FB-29B78E881C9C}"/>
               </a:ext>
             </a:extLst>
           </p:cNvPr>
@@ -1933,7 +1933,7 @@
           <p:cNvPr id="6" name="Content Placeholder 5">
             <a:extLst>
               <a:ext uri="{FF2B5EF4-FFF2-40B4-BE49-F238E27FC236}">
-                <a16:creationId xmlns:a16="http://schemas.microsoft.com/office/drawing/2014/main" id="{4C54A9F6-3B9F-A7D0-6C99-2A74CE7B709A}"/>
+                <a16:creationId xmlns:a16="http://schemas.microsoft.com/office/drawing/2014/main" id="{4BBA8217-2601-96D1-A8B8-E8CDECD4839F}"/>
               </a:ext>
             </a:extLst>
           </p:cNvPr>
@@ -1995,7 +1995,7 @@
           <p:cNvPr id="7" name="Date Placeholder 6">
             <a:extLst>
               <a:ext uri="{FF2B5EF4-FFF2-40B4-BE49-F238E27FC236}">
-                <a16:creationId xmlns:a16="http://schemas.microsoft.com/office/drawing/2014/main" id="{3A59E387-CA3A-F344-AFC7-34D5CBC068F1}"/>
+                <a16:creationId xmlns:a16="http://schemas.microsoft.com/office/drawing/2014/main" id="{7B8CF106-540B-C73A-6CBB-ABC5BD296D9B}"/>
               </a:ext>
             </a:extLst>
           </p:cNvPr>
@@ -2011,9 +2011,9 @@
           <a:bodyPr/>
           <a:lstStyle/>
           <a:p>
-            <a:fld id="{D6CBD7AF-9F59-4387-953D-7AF4223CD7B2}" type="datetimeFigureOut">
+            <a:fld id="{424CA8A1-6869-4F6F-94B9-4672574CFC1C}" type="datetimeFigureOut">
               <a:rPr lang="en-US" smtClean="0"/>
-              <a:t>9/17/2026</a:t>
+              <a:t>9/19/2026</a:t>
             </a:fld>
             <a:endParaRPr lang="en-US"/>
           </a:p>
@@ -2024,7 +2024,7 @@
           <p:cNvPr id="8" name="Footer Placeholder 7">
             <a:extLst>
               <a:ext uri="{FF2B5EF4-FFF2-40B4-BE49-F238E27FC236}">
-                <a16:creationId xmlns:a16="http://schemas.microsoft.com/office/drawing/2014/main" id="{BE12F410-C22C-DD6E-97BE-65899B73F717}"/>
+                <a16:creationId xmlns:a16="http://schemas.microsoft.com/office/drawing/2014/main" id="{EF4DC3E2-524D-C04C-6485-5253ACFEB253}"/>
               </a:ext>
             </a:extLst>
           </p:cNvPr>
@@ -2049,7 +2049,7 @@
           <p:cNvPr id="9" name="Slide Number Placeholder 8">
             <a:extLst>
               <a:ext uri="{FF2B5EF4-FFF2-40B4-BE49-F238E27FC236}">
-                <a16:creationId xmlns:a16="http://schemas.microsoft.com/office/drawing/2014/main" id="{B6A743EB-4BE1-BF4F-D8A6-6C79F3709D5B}"/>
+                <a16:creationId xmlns:a16="http://schemas.microsoft.com/office/drawing/2014/main" id="{A77FAC3F-69DE-AC5F-9414-F3E07DE115A0}"/>
               </a:ext>
             </a:extLst>
           </p:cNvPr>
@@ -2065,7 +2065,7 @@
           <a:bodyPr/>
           <a:lstStyle/>
           <a:p>
-            <a:fld id="{9D915052-6BD4-4097-932F-7C78C6FCA82D}" type="slidenum">
+            <a:fld id="{88F39F1B-68C9-456A-BB80-0F545E82F8A5}" type="slidenum">
               <a:rPr lang="en-US" smtClean="0"/>
               <a:t>‹#›</a:t>
             </a:fld>
@@ -2076,7 +2076,7 @@
     </p:spTree>
     <p:extLst>
       <p:ext uri="{BB962C8B-B14F-4D97-AF65-F5344CB8AC3E}">
-        <p14:creationId xmlns:p14="http://schemas.microsoft.com/office/powerpoint/2010/main" val="471770677"/>
+        <p14:creationId xmlns:p14="http://schemas.microsoft.com/office/powerpoint/2010/main" val="2549621867"/>
       </p:ext>
     </p:extLst>
   </p:cSld>
@@ -2108,7 +2108,7 @@
           <p:cNvPr id="2" name="Title 1">
             <a:extLst>
               <a:ext uri="{FF2B5EF4-FFF2-40B4-BE49-F238E27FC236}">
-                <a16:creationId xmlns:a16="http://schemas.microsoft.com/office/drawing/2014/main" id="{9156EF4C-674C-5500-DBA5-8C1AD1D8AF17}"/>
+                <a16:creationId xmlns:a16="http://schemas.microsoft.com/office/drawing/2014/main" id="{942D8D18-57E0-F4C0-D9F0-E057934C2BB0}"/>
               </a:ext>
             </a:extLst>
           </p:cNvPr>
@@ -2136,7 +2136,7 @@
           <p:cNvPr id="3" name="Date Placeholder 2">
             <a:extLst>
               <a:ext uri="{FF2B5EF4-FFF2-40B4-BE49-F238E27FC236}">
-                <a16:creationId xmlns:a16="http://schemas.microsoft.com/office/drawing/2014/main" id="{FC692A80-57FD-F47A-7E1D-D18DEB449EDC}"/>
+                <a16:creationId xmlns:a16="http://schemas.microsoft.com/office/drawing/2014/main" id="{309EA8B0-89D6-7069-C1E9-00C773F1BFF2}"/>
               </a:ext>
             </a:extLst>
           </p:cNvPr>
@@ -2152,9 +2152,9 @@
           <a:bodyPr/>
           <a:lstStyle/>
           <a:p>
-            <a:fld id="{D6CBD7AF-9F59-4387-953D-7AF4223CD7B2}" type="datetimeFigureOut">
+            <a:fld id="{424CA8A1-6869-4F6F-94B9-4672574CFC1C}" type="datetimeFigureOut">
               <a:rPr lang="en-US" smtClean="0"/>
-              <a:t>9/17/2026</a:t>
+              <a:t>9/19/2026</a:t>
             </a:fld>
             <a:endParaRPr lang="en-US"/>
           </a:p>
@@ -2165,7 +2165,7 @@
           <p:cNvPr id="4" name="Footer Placeholder 3">
             <a:extLst>
               <a:ext uri="{FF2B5EF4-FFF2-40B4-BE49-F238E27FC236}">
-                <a16:creationId xmlns:a16="http://schemas.microsoft.com/office/drawing/2014/main" id="{08884598-E574-4C98-4ECD-D596B2C1A811}"/>
+                <a16:creationId xmlns:a16="http://schemas.microsoft.com/office/drawing/2014/main" id="{7FA13183-6397-F3EA-15F3-259C8201B42C}"/>
               </a:ext>
             </a:extLst>
           </p:cNvPr>
@@ -2190,7 +2190,7 @@
           <p:cNvPr id="5" name="Slide Number Placeholder 4">
             <a:extLst>
               <a:ext uri="{FF2B5EF4-FFF2-40B4-BE49-F238E27FC236}">
-                <a16:creationId xmlns:a16="http://schemas.microsoft.com/office/drawing/2014/main" id="{15F71FEA-8015-0C89-74BA-DDE7D2665AD7}"/>
+                <a16:creationId xmlns:a16="http://schemas.microsoft.com/office/drawing/2014/main" id="{CD161AC6-DA4C-89FE-265F-8B853163FFF3}"/>
               </a:ext>
             </a:extLst>
           </p:cNvPr>
@@ -2206,7 +2206,7 @@
           <a:bodyPr/>
           <a:lstStyle/>
           <a:p>
-            <a:fld id="{9D915052-6BD4-4097-932F-7C78C6FCA82D}" type="slidenum">
+            <a:fld id="{88F39F1B-68C9-456A-BB80-0F545E82F8A5}" type="slidenum">
               <a:rPr lang="en-US" smtClean="0"/>
               <a:t>‹#›</a:t>
             </a:fld>
@@ -2217,7 +2217,7 @@
     </p:spTree>
     <p:extLst>
       <p:ext uri="{BB962C8B-B14F-4D97-AF65-F5344CB8AC3E}">
-        <p14:creationId xmlns:p14="http://schemas.microsoft.com/office/powerpoint/2010/main" val="3822330277"/>
+        <p14:creationId xmlns:p14="http://schemas.microsoft.com/office/powerpoint/2010/main" val="2243093592"/>
       </p:ext>
     </p:extLst>
   </p:cSld>
@@ -2249,7 +2249,7 @@
           <p:cNvPr id="2" name="Date Placeholder 1">
             <a:extLst>
               <a:ext uri="{FF2B5EF4-FFF2-40B4-BE49-F238E27FC236}">
-                <a16:creationId xmlns:a16="http://schemas.microsoft.com/office/drawing/2014/main" id="{65708ECA-C70F-A8D2-191C-5073EEFEFB68}"/>
+                <a16:creationId xmlns:a16="http://schemas.microsoft.com/office/drawing/2014/main" id="{ABAD0D8C-F57A-8722-3C34-7705B1477F19}"/>
               </a:ext>
             </a:extLst>
           </p:cNvPr>
@@ -2265,9 +2265,9 @@
           <a:bodyPr/>
           <a:lstStyle/>
           <a:p>
-            <a:fld id="{D6CBD7AF-9F59-4387-953D-7AF4223CD7B2}" type="datetimeFigureOut">
+            <a:fld id="{424CA8A1-6869-4F6F-94B9-4672574CFC1C}" type="datetimeFigureOut">
               <a:rPr lang="en-US" smtClean="0"/>
-              <a:t>9/17/2026</a:t>
+              <a:t>9/19/2026</a:t>
             </a:fld>
             <a:endParaRPr lang="en-US"/>
           </a:p>
@@ -2278,7 +2278,7 @@
           <p:cNvPr id="3" name="Footer Placeholder 2">
             <a:extLst>
               <a:ext uri="{FF2B5EF4-FFF2-40B4-BE49-F238E27FC236}">
-                <a16:creationId xmlns:a16="http://schemas.microsoft.com/office/drawing/2014/main" id="{DCC5FD7A-2939-19DB-7C7E-5D773DD13DBA}"/>
+                <a16:creationId xmlns:a16="http://schemas.microsoft.com/office/drawing/2014/main" id="{E1C876E9-1083-D7F8-A6E0-32DF8230714B}"/>
               </a:ext>
             </a:extLst>
           </p:cNvPr>
@@ -2303,7 +2303,7 @@
           <p:cNvPr id="4" name="Slide Number Placeholder 3">
             <a:extLst>
               <a:ext uri="{FF2B5EF4-FFF2-40B4-BE49-F238E27FC236}">
-                <a16:creationId xmlns:a16="http://schemas.microsoft.com/office/drawing/2014/main" id="{9DB01BD3-4ED7-E72B-AD20-E541ED917D07}"/>
+                <a16:creationId xmlns:a16="http://schemas.microsoft.com/office/drawing/2014/main" id="{D4EC789F-7D41-78A0-0CA3-A36F0E4F405F}"/>
               </a:ext>
             </a:extLst>
           </p:cNvPr>
@@ -2319,7 +2319,7 @@
           <a:bodyPr/>
           <a:lstStyle/>
           <a:p>
-            <a:fld id="{9D915052-6BD4-4097-932F-7C78C6FCA82D}" type="slidenum">
+            <a:fld id="{88F39F1B-68C9-456A-BB80-0F545E82F8A5}" type="slidenum">
               <a:rPr lang="en-US" smtClean="0"/>
               <a:t>‹#›</a:t>
             </a:fld>
@@ -2330,7 +2330,7 @@
     </p:spTree>
     <p:extLst>
       <p:ext uri="{BB962C8B-B14F-4D97-AF65-F5344CB8AC3E}">
-        <p14:creationId xmlns:p14="http://schemas.microsoft.com/office/powerpoint/2010/main" val="2711516705"/>
+        <p14:creationId xmlns:p14="http://schemas.microsoft.com/office/powerpoint/2010/main" val="1351416534"/>
       </p:ext>
     </p:extLst>
   </p:cSld>
@@ -2362,7 +2362,7 @@
           <p:cNvPr id="2" name="Title 1">
             <a:extLst>
               <a:ext uri="{FF2B5EF4-FFF2-40B4-BE49-F238E27FC236}">
-                <a16:creationId xmlns:a16="http://schemas.microsoft.com/office/drawing/2014/main" id="{E2483863-7721-1B33-13D7-533B5F57856E}"/>
+                <a16:creationId xmlns:a16="http://schemas.microsoft.com/office/drawing/2014/main" id="{C38711E7-14BC-85A0-3CC4-B2CE975ACCA9}"/>
               </a:ext>
             </a:extLst>
           </p:cNvPr>
@@ -2399,7 +2399,7 @@
           <p:cNvPr id="3" name="Content Placeholder 2">
             <a:extLst>
               <a:ext uri="{FF2B5EF4-FFF2-40B4-BE49-F238E27FC236}">
-                <a16:creationId xmlns:a16="http://schemas.microsoft.com/office/drawing/2014/main" id="{ACA1D686-3E6F-0FAC-8265-3AF76849AD0C}"/>
+                <a16:creationId xmlns:a16="http://schemas.microsoft.com/office/drawing/2014/main" id="{0993C4A5-8BEF-6D3E-6832-9D0964A220D1}"/>
               </a:ext>
             </a:extLst>
           </p:cNvPr>
@@ -2489,7 +2489,7 @@
           <p:cNvPr id="4" name="Text Placeholder 3">
             <a:extLst>
               <a:ext uri="{FF2B5EF4-FFF2-40B4-BE49-F238E27FC236}">
-                <a16:creationId xmlns:a16="http://schemas.microsoft.com/office/drawing/2014/main" id="{C3F4B8E7-6812-46FA-11F0-CAD543409399}"/>
+                <a16:creationId xmlns:a16="http://schemas.microsoft.com/office/drawing/2014/main" id="{58C0CD2A-1B0E-C05C-D7A0-0949F558911D}"/>
               </a:ext>
             </a:extLst>
           </p:cNvPr>
@@ -2560,7 +2560,7 @@
           <p:cNvPr id="5" name="Date Placeholder 4">
             <a:extLst>
               <a:ext uri="{FF2B5EF4-FFF2-40B4-BE49-F238E27FC236}">
-                <a16:creationId xmlns:a16="http://schemas.microsoft.com/office/drawing/2014/main" id="{A48EC900-90AB-C9AA-C3E7-6112E7F658CA}"/>
+                <a16:creationId xmlns:a16="http://schemas.microsoft.com/office/drawing/2014/main" id="{BFBBFB42-E674-A724-ED75-84772C60F5E1}"/>
               </a:ext>
             </a:extLst>
           </p:cNvPr>
@@ -2576,9 +2576,9 @@
           <a:bodyPr/>
           <a:lstStyle/>
           <a:p>
-            <a:fld id="{D6CBD7AF-9F59-4387-953D-7AF4223CD7B2}" type="datetimeFigureOut">
+            <a:fld id="{424CA8A1-6869-4F6F-94B9-4672574CFC1C}" type="datetimeFigureOut">
               <a:rPr lang="en-US" smtClean="0"/>
-              <a:t>9/17/2026</a:t>
+              <a:t>9/19/2026</a:t>
             </a:fld>
             <a:endParaRPr lang="en-US"/>
           </a:p>
@@ -2589,7 +2589,7 @@
           <p:cNvPr id="6" name="Footer Placeholder 5">
             <a:extLst>
               <a:ext uri="{FF2B5EF4-FFF2-40B4-BE49-F238E27FC236}">
-                <a16:creationId xmlns:a16="http://schemas.microsoft.com/office/drawing/2014/main" id="{089F5B53-D011-75D6-D286-C42202F1F8BF}"/>
+                <a16:creationId xmlns:a16="http://schemas.microsoft.com/office/drawing/2014/main" id="{F1DEB7C2-F137-FE8B-58F2-78627C858CDB}"/>
               </a:ext>
             </a:extLst>
           </p:cNvPr>
@@ -2614,7 +2614,7 @@
           <p:cNvPr id="7" name="Slide Number Placeholder 6">
             <a:extLst>
               <a:ext uri="{FF2B5EF4-FFF2-40B4-BE49-F238E27FC236}">
-                <a16:creationId xmlns:a16="http://schemas.microsoft.com/office/drawing/2014/main" id="{CA28983C-944B-AD93-AC52-A0E8560D9252}"/>
+                <a16:creationId xmlns:a16="http://schemas.microsoft.com/office/drawing/2014/main" id="{130701FD-3F73-F286-3EE4-AF3A77AC36F3}"/>
               </a:ext>
             </a:extLst>
           </p:cNvPr>
@@ -2630,7 +2630,7 @@
           <a:bodyPr/>
           <a:lstStyle/>
           <a:p>
-            <a:fld id="{9D915052-6BD4-4097-932F-7C78C6FCA82D}" type="slidenum">
+            <a:fld id="{88F39F1B-68C9-456A-BB80-0F545E82F8A5}" type="slidenum">
               <a:rPr lang="en-US" smtClean="0"/>
               <a:t>‹#›</a:t>
             </a:fld>
@@ -2641,7 +2641,7 @@
     </p:spTree>
     <p:extLst>
       <p:ext uri="{BB962C8B-B14F-4D97-AF65-F5344CB8AC3E}">
-        <p14:creationId xmlns:p14="http://schemas.microsoft.com/office/powerpoint/2010/main" val="3438056307"/>
+        <p14:creationId xmlns:p14="http://schemas.microsoft.com/office/powerpoint/2010/main" val="2453200194"/>
       </p:ext>
     </p:extLst>
   </p:cSld>
@@ -2673,7 +2673,7 @@
           <p:cNvPr id="2" name="Title 1">
             <a:extLst>
               <a:ext uri="{FF2B5EF4-FFF2-40B4-BE49-F238E27FC236}">
-                <a16:creationId xmlns:a16="http://schemas.microsoft.com/office/drawing/2014/main" id="{58B71932-2BD8-5DE7-F678-ECF9639A6360}"/>
+                <a16:creationId xmlns:a16="http://schemas.microsoft.com/office/drawing/2014/main" id="{E90C612E-D87D-9301-CE00-04B664BA7288}"/>
               </a:ext>
             </a:extLst>
           </p:cNvPr>
@@ -2710,12 +2710,12 @@
           <p:cNvPr id="3" name="Picture Placeholder 2">
             <a:extLst>
               <a:ext uri="{FF2B5EF4-FFF2-40B4-BE49-F238E27FC236}">
-                <a16:creationId xmlns:a16="http://schemas.microsoft.com/office/drawing/2014/main" id="{3FD5DA28-7B48-65A7-33F2-9BA4F16BCBD4}"/>
-              </a:ext>
-            </a:extLst>
-          </p:cNvPr>
-          <p:cNvSpPr>
-            <a:spLocks noGrp="1" noChangeAspect="1"/>
+                <a16:creationId xmlns:a16="http://schemas.microsoft.com/office/drawing/2014/main" id="{7792DA54-BA89-7CA4-16FF-A3A1CE2F82EA}"/>
+              </a:ext>
+            </a:extLst>
+          </p:cNvPr>
+          <p:cNvSpPr>
+            <a:spLocks noGrp="1"/>
           </p:cNvSpPr>
           <p:nvPr>
             <p:ph type="pic" idx="1"/>
@@ -2777,7 +2777,7 @@
           <p:cNvPr id="4" name="Text Placeholder 3">
             <a:extLst>
               <a:ext uri="{FF2B5EF4-FFF2-40B4-BE49-F238E27FC236}">
-                <a16:creationId xmlns:a16="http://schemas.microsoft.com/office/drawing/2014/main" id="{6A53C4D4-4847-9744-3F18-D94B8E66528B}"/>
+                <a16:creationId xmlns:a16="http://schemas.microsoft.com/office/drawing/2014/main" id="{31A14494-E39B-E648-D118-1E5EE0A5AA1E}"/>
               </a:ext>
             </a:extLst>
           </p:cNvPr>
@@ -2848,7 +2848,7 @@
           <p:cNvPr id="5" name="Date Placeholder 4">
             <a:extLst>
               <a:ext uri="{FF2B5EF4-FFF2-40B4-BE49-F238E27FC236}">
-                <a16:creationId xmlns:a16="http://schemas.microsoft.com/office/drawing/2014/main" id="{7913602B-D7D6-E67A-E863-F4F3F230C45A}"/>
+                <a16:creationId xmlns:a16="http://schemas.microsoft.com/office/drawing/2014/main" id="{9F17BF0F-3A27-7504-FF00-64E4A971872C}"/>
               </a:ext>
             </a:extLst>
           </p:cNvPr>
@@ -2864,9 +2864,9 @@
           <a:bodyPr/>
           <a:lstStyle/>
           <a:p>
-            <a:fld id="{D6CBD7AF-9F59-4387-953D-7AF4223CD7B2}" type="datetimeFigureOut">
+            <a:fld id="{424CA8A1-6869-4F6F-94B9-4672574CFC1C}" type="datetimeFigureOut">
               <a:rPr lang="en-US" smtClean="0"/>
-              <a:t>9/17/2026</a:t>
+              <a:t>9/19/2026</a:t>
             </a:fld>
             <a:endParaRPr lang="en-US"/>
           </a:p>
@@ -2877,7 +2877,7 @@
           <p:cNvPr id="6" name="Footer Placeholder 5">
             <a:extLst>
               <a:ext uri="{FF2B5EF4-FFF2-40B4-BE49-F238E27FC236}">
-                <a16:creationId xmlns:a16="http://schemas.microsoft.com/office/drawing/2014/main" id="{DD9D52AC-420B-E1D6-3606-2BC79F1AA225}"/>
+                <a16:creationId xmlns:a16="http://schemas.microsoft.com/office/drawing/2014/main" id="{DFD2557B-F427-4230-0F9F-106AE6E09AC5}"/>
               </a:ext>
             </a:extLst>
           </p:cNvPr>
@@ -2902,7 +2902,7 @@
           <p:cNvPr id="7" name="Slide Number Placeholder 6">
             <a:extLst>
               <a:ext uri="{FF2B5EF4-FFF2-40B4-BE49-F238E27FC236}">
-                <a16:creationId xmlns:a16="http://schemas.microsoft.com/office/drawing/2014/main" id="{931A4BEC-DD7D-73BE-BA80-4401803926BC}"/>
+                <a16:creationId xmlns:a16="http://schemas.microsoft.com/office/drawing/2014/main" id="{F1BE2517-7C4C-721E-901C-B8AC2038435D}"/>
               </a:ext>
             </a:extLst>
           </p:cNvPr>
@@ -2918,7 +2918,7 @@
           <a:bodyPr/>
           <a:lstStyle/>
           <a:p>
-            <a:fld id="{9D915052-6BD4-4097-932F-7C78C6FCA82D}" type="slidenum">
+            <a:fld id="{88F39F1B-68C9-456A-BB80-0F545E82F8A5}" type="slidenum">
               <a:rPr lang="en-US" smtClean="0"/>
               <a:t>‹#›</a:t>
             </a:fld>
@@ -2929,7 +2929,7 @@
     </p:spTree>
     <p:extLst>
       <p:ext uri="{BB962C8B-B14F-4D97-AF65-F5344CB8AC3E}">
-        <p14:creationId xmlns:p14="http://schemas.microsoft.com/office/powerpoint/2010/main" val="3877192563"/>
+        <p14:creationId xmlns:p14="http://schemas.microsoft.com/office/powerpoint/2010/main" val="1377079673"/>
       </p:ext>
     </p:extLst>
   </p:cSld>
@@ -2966,7 +2966,7 @@
           <p:cNvPr id="2" name="Title Placeholder 1">
             <a:extLst>
               <a:ext uri="{FF2B5EF4-FFF2-40B4-BE49-F238E27FC236}">
-                <a16:creationId xmlns:a16="http://schemas.microsoft.com/office/drawing/2014/main" id="{41908EC3-974A-63CB-CA21-6CE346F4CF36}"/>
+                <a16:creationId xmlns:a16="http://schemas.microsoft.com/office/drawing/2014/main" id="{47DE216D-319D-2F1E-D104-BF2CA08AAE81}"/>
               </a:ext>
             </a:extLst>
           </p:cNvPr>
@@ -3004,7 +3004,7 @@
           <p:cNvPr id="3" name="Text Placeholder 2">
             <a:extLst>
               <a:ext uri="{FF2B5EF4-FFF2-40B4-BE49-F238E27FC236}">
-                <a16:creationId xmlns:a16="http://schemas.microsoft.com/office/drawing/2014/main" id="{B580FCC7-FD76-89E1-EA1C-230BEB97C5BA}"/>
+                <a16:creationId xmlns:a16="http://schemas.microsoft.com/office/drawing/2014/main" id="{23F4609A-235E-B381-8235-71A209D79CBF}"/>
               </a:ext>
             </a:extLst>
           </p:cNvPr>
@@ -3071,7 +3071,7 @@
           <p:cNvPr id="4" name="Date Placeholder 3">
             <a:extLst>
               <a:ext uri="{FF2B5EF4-FFF2-40B4-BE49-F238E27FC236}">
-                <a16:creationId xmlns:a16="http://schemas.microsoft.com/office/drawing/2014/main" id="{2B68BDE8-7631-5DBF-3698-7D70E96D94CC}"/>
+                <a16:creationId xmlns:a16="http://schemas.microsoft.com/office/drawing/2014/main" id="{E655B61B-8438-14F0-FD61-9FB3B21D9F29}"/>
               </a:ext>
             </a:extLst>
           </p:cNvPr>
@@ -3105,9 +3105,9 @@
             </a:lvl1pPr>
           </a:lstStyle>
           <a:p>
-            <a:fld id="{D6CBD7AF-9F59-4387-953D-7AF4223CD7B2}" type="datetimeFigureOut">
+            <a:fld id="{424CA8A1-6869-4F6F-94B9-4672574CFC1C}" type="datetimeFigureOut">
               <a:rPr lang="en-US" smtClean="0"/>
-              <a:t>9/17/2026</a:t>
+              <a:t>9/19/2026</a:t>
             </a:fld>
             <a:endParaRPr lang="en-US"/>
           </a:p>
@@ -3118,7 +3118,7 @@
           <p:cNvPr id="5" name="Footer Placeholder 4">
             <a:extLst>
               <a:ext uri="{FF2B5EF4-FFF2-40B4-BE49-F238E27FC236}">
-                <a16:creationId xmlns:a16="http://schemas.microsoft.com/office/drawing/2014/main" id="{CAEB29BD-0826-4FB6-552E-E5474102790C}"/>
+                <a16:creationId xmlns:a16="http://schemas.microsoft.com/office/drawing/2014/main" id="{9F79B3FF-D4A3-DC13-4651-FF44C5DFBA63}"/>
               </a:ext>
             </a:extLst>
           </p:cNvPr>
@@ -3161,7 +3161,7 @@
           <p:cNvPr id="6" name="Slide Number Placeholder 5">
             <a:extLst>
               <a:ext uri="{FF2B5EF4-FFF2-40B4-BE49-F238E27FC236}">
-                <a16:creationId xmlns:a16="http://schemas.microsoft.com/office/drawing/2014/main" id="{0D25B0F4-AED1-AE30-4A0F-05CE7FA1DDE8}"/>
+                <a16:creationId xmlns:a16="http://schemas.microsoft.com/office/drawing/2014/main" id="{B540FB1A-C3D3-17C0-4CCC-BC7DC210AC9C}"/>
               </a:ext>
             </a:extLst>
           </p:cNvPr>
@@ -3195,7 +3195,7 @@
             </a:lvl1pPr>
           </a:lstStyle>
           <a:p>
-            <a:fld id="{9D915052-6BD4-4097-932F-7C78C6FCA82D}" type="slidenum">
+            <a:fld id="{88F39F1B-68C9-456A-BB80-0F545E82F8A5}" type="slidenum">
               <a:rPr lang="en-US" smtClean="0"/>
               <a:t>‹#›</a:t>
             </a:fld>
@@ -3206,7 +3206,7 @@
     </p:spTree>
     <p:extLst>
       <p:ext uri="{BB962C8B-B14F-4D97-AF65-F5344CB8AC3E}">
-        <p14:creationId xmlns:p14="http://schemas.microsoft.com/office/powerpoint/2010/main" val="2697435347"/>
+        <p14:creationId xmlns:p14="http://schemas.microsoft.com/office/powerpoint/2010/main" val="1575396871"/>
       </p:ext>
     </p:extLst>
   </p:cSld>
@@ -3538,7 +3538,7 @@
           <p:cNvPr id="2" name="Title 1">
             <a:extLst>
               <a:ext uri="{FF2B5EF4-FFF2-40B4-BE49-F238E27FC236}">
-                <a16:creationId xmlns:a16="http://schemas.microsoft.com/office/drawing/2014/main" id="{47E5594A-C2B6-493F-9738-B8569E60EBB2}"/>
+                <a16:creationId xmlns:a16="http://schemas.microsoft.com/office/drawing/2014/main" id="{CE90B42B-CEC5-272E-6732-16D6DE2AD92D}"/>
               </a:ext>
             </a:extLst>
           </p:cNvPr>
@@ -3573,7 +3573,7 @@
           <p:cNvPr id="3" name="Subtitle 2">
             <a:extLst>
               <a:ext uri="{FF2B5EF4-FFF2-40B4-BE49-F238E27FC236}">
-                <a16:creationId xmlns:a16="http://schemas.microsoft.com/office/drawing/2014/main" id="{4FF62C04-AB36-D345-876D-DF85B58910C3}"/>
+                <a16:creationId xmlns:a16="http://schemas.microsoft.com/office/drawing/2014/main" id="{CB32BB7E-892C-3D6B-6AA6-DA7FE2C9BE8A}"/>
               </a:ext>
             </a:extLst>
           </p:cNvPr>
@@ -3614,7 +3614,7 @@
           <p:cNvPr id="4" name="Rectangle 3">
             <a:extLst>
               <a:ext uri="{FF2B5EF4-FFF2-40B4-BE49-F238E27FC236}">
-                <a16:creationId xmlns:a16="http://schemas.microsoft.com/office/drawing/2014/main" id="{AA53E072-E5B9-1426-C713-4A9EC689BFE0}"/>
+                <a16:creationId xmlns:a16="http://schemas.microsoft.com/office/drawing/2014/main" id="{F5F7491B-CDC7-0D4F-4F1F-F3EC3C8239F4}"/>
               </a:ext>
             </a:extLst>
           </p:cNvPr>
@@ -3682,7 +3682,7 @@
           <p:cNvPr id="5" name="TextBox 4">
             <a:extLst>
               <a:ext uri="{FF2B5EF4-FFF2-40B4-BE49-F238E27FC236}">
-                <a16:creationId xmlns:a16="http://schemas.microsoft.com/office/drawing/2014/main" id="{43C53857-4DF4-A0AD-432A-030909F9E040}"/>
+                <a16:creationId xmlns:a16="http://schemas.microsoft.com/office/drawing/2014/main" id="{C5EF0FA2-C25E-3AB8-60F8-6B401C2DFEB5}"/>
               </a:ext>
             </a:extLst>
           </p:cNvPr>
@@ -3720,7 +3720,7 @@
     </p:spTree>
     <p:extLst>
       <p:ext uri="{BB962C8B-B14F-4D97-AF65-F5344CB8AC3E}">
-        <p14:creationId xmlns:p14="http://schemas.microsoft.com/office/powerpoint/2010/main" val="2888546792"/>
+        <p14:creationId xmlns:p14="http://schemas.microsoft.com/office/powerpoint/2010/main" val="18075380"/>
       </p:ext>
     </p:extLst>
   </p:cSld>
@@ -3760,7 +3760,7 @@
           <p:cNvPr id="2" name="Title 1">
             <a:extLst>
               <a:ext uri="{FF2B5EF4-FFF2-40B4-BE49-F238E27FC236}">
-                <a16:creationId xmlns:a16="http://schemas.microsoft.com/office/drawing/2014/main" id="{206C3C40-7AFE-1762-BDFE-44DE4C1978D5}"/>
+                <a16:creationId xmlns:a16="http://schemas.microsoft.com/office/drawing/2014/main" id="{24DF8FB3-6730-FE95-15D4-7B0ADB383834}"/>
               </a:ext>
             </a:extLst>
           </p:cNvPr>
@@ -3795,7 +3795,7 @@
           <p:cNvPr id="3" name="Text Placeholder 2">
             <a:extLst>
               <a:ext uri="{FF2B5EF4-FFF2-40B4-BE49-F238E27FC236}">
-                <a16:creationId xmlns:a16="http://schemas.microsoft.com/office/drawing/2014/main" id="{62F1C8CB-2355-62F5-9E07-FFEC5EDB7F45}"/>
+                <a16:creationId xmlns:a16="http://schemas.microsoft.com/office/drawing/2014/main" id="{37E5033F-0E0A-1ADE-C2D4-1D4A2E9CF222}"/>
               </a:ext>
             </a:extLst>
           </p:cNvPr>
@@ -3869,7 +3869,7 @@
           <p:cNvPr id="4" name="Rectangle 3">
             <a:extLst>
               <a:ext uri="{FF2B5EF4-FFF2-40B4-BE49-F238E27FC236}">
-                <a16:creationId xmlns:a16="http://schemas.microsoft.com/office/drawing/2014/main" id="{A91CAEE9-DB9C-654E-3E4C-20E6CF83F5E5}"/>
+                <a16:creationId xmlns:a16="http://schemas.microsoft.com/office/drawing/2014/main" id="{2B75B4E5-F40B-555E-E90C-299F1A07924B}"/>
               </a:ext>
             </a:extLst>
           </p:cNvPr>
@@ -3937,7 +3937,7 @@
           <p:cNvPr id="5" name="TextBox 4">
             <a:extLst>
               <a:ext uri="{FF2B5EF4-FFF2-40B4-BE49-F238E27FC236}">
-                <a16:creationId xmlns:a16="http://schemas.microsoft.com/office/drawing/2014/main" id="{74581213-D70D-5BBE-6C59-40135045004E}"/>
+                <a16:creationId xmlns:a16="http://schemas.microsoft.com/office/drawing/2014/main" id="{338A465B-5981-3C5E-B18C-A5298631F32F}"/>
               </a:ext>
             </a:extLst>
           </p:cNvPr>
@@ -3975,7 +3975,7 @@
     </p:spTree>
     <p:extLst>
       <p:ext uri="{BB962C8B-B14F-4D97-AF65-F5344CB8AC3E}">
-        <p14:creationId xmlns:p14="http://schemas.microsoft.com/office/powerpoint/2010/main" val="1355435755"/>
+        <p14:creationId xmlns:p14="http://schemas.microsoft.com/office/powerpoint/2010/main" val="2046965455"/>
       </p:ext>
     </p:extLst>
   </p:cSld>
@@ -4015,7 +4015,7 @@
           <p:cNvPr id="2" name="Title 1">
             <a:extLst>
               <a:ext uri="{FF2B5EF4-FFF2-40B4-BE49-F238E27FC236}">
-                <a16:creationId xmlns:a16="http://schemas.microsoft.com/office/drawing/2014/main" id="{CF8E7C6C-76A6-9E4D-FD63-C42A96FBA28D}"/>
+                <a16:creationId xmlns:a16="http://schemas.microsoft.com/office/drawing/2014/main" id="{8AD5851B-225E-1933-42E4-114C006532DB}"/>
               </a:ext>
             </a:extLst>
           </p:cNvPr>
@@ -4050,7 +4050,7 @@
           <p:cNvPr id="3" name="Text Placeholder 2">
             <a:extLst>
               <a:ext uri="{FF2B5EF4-FFF2-40B4-BE49-F238E27FC236}">
-                <a16:creationId xmlns:a16="http://schemas.microsoft.com/office/drawing/2014/main" id="{0886A41D-A67F-8E95-A5DF-FE58A0B0A94E}"/>
+                <a16:creationId xmlns:a16="http://schemas.microsoft.com/office/drawing/2014/main" id="{960F44EE-E326-0FB0-CFE3-2A2BEDC5303D}"/>
               </a:ext>
             </a:extLst>
           </p:cNvPr>
@@ -4124,7 +4124,7 @@
           <p:cNvPr id="4" name="Rectangle 3">
             <a:extLst>
               <a:ext uri="{FF2B5EF4-FFF2-40B4-BE49-F238E27FC236}">
-                <a16:creationId xmlns:a16="http://schemas.microsoft.com/office/drawing/2014/main" id="{D25C4576-ADA6-C7B4-ABEA-A6DFC964C9FE}"/>
+                <a16:creationId xmlns:a16="http://schemas.microsoft.com/office/drawing/2014/main" id="{3732A0DC-2A85-C28E-727B-6A4ACB2F442A}"/>
               </a:ext>
             </a:extLst>
           </p:cNvPr>
@@ -4192,7 +4192,7 @@
           <p:cNvPr id="5" name="TextBox 4">
             <a:extLst>
               <a:ext uri="{FF2B5EF4-FFF2-40B4-BE49-F238E27FC236}">
-                <a16:creationId xmlns:a16="http://schemas.microsoft.com/office/drawing/2014/main" id="{9CDE8C74-67CD-91A7-C1AD-8DF645B59B82}"/>
+                <a16:creationId xmlns:a16="http://schemas.microsoft.com/office/drawing/2014/main" id="{1A417F50-91DA-706B-0AAF-FA96E521D61B}"/>
               </a:ext>
             </a:extLst>
           </p:cNvPr>
@@ -4230,7 +4230,7 @@
     </p:spTree>
     <p:extLst>
       <p:ext uri="{BB962C8B-B14F-4D97-AF65-F5344CB8AC3E}">
-        <p14:creationId xmlns:p14="http://schemas.microsoft.com/office/powerpoint/2010/main" val="3782435730"/>
+        <p14:creationId xmlns:p14="http://schemas.microsoft.com/office/powerpoint/2010/main" val="632960965"/>
       </p:ext>
     </p:extLst>
   </p:cSld>
@@ -4270,7 +4270,7 @@
           <p:cNvPr id="2" name="Title 1">
             <a:extLst>
               <a:ext uri="{FF2B5EF4-FFF2-40B4-BE49-F238E27FC236}">
-                <a16:creationId xmlns:a16="http://schemas.microsoft.com/office/drawing/2014/main" id="{5A469AE1-265F-6D66-D703-A07A3E84ED20}"/>
+                <a16:creationId xmlns:a16="http://schemas.microsoft.com/office/drawing/2014/main" id="{936EC0A9-4389-65F6-2A8F-157E98F9B06D}"/>
               </a:ext>
             </a:extLst>
           </p:cNvPr>
@@ -4305,7 +4305,7 @@
           <p:cNvPr id="3" name="Text Placeholder 2">
             <a:extLst>
               <a:ext uri="{FF2B5EF4-FFF2-40B4-BE49-F238E27FC236}">
-                <a16:creationId xmlns:a16="http://schemas.microsoft.com/office/drawing/2014/main" id="{562EF103-1370-9A8A-6BB8-CD1F79AEB636}"/>
+                <a16:creationId xmlns:a16="http://schemas.microsoft.com/office/drawing/2014/main" id="{736BE5E3-9D04-5856-EB08-D0F31D2765C5}"/>
               </a:ext>
             </a:extLst>
           </p:cNvPr>
@@ -4390,7 +4390,7 @@
           <p:cNvPr id="4" name="Rectangle 3">
             <a:extLst>
               <a:ext uri="{FF2B5EF4-FFF2-40B4-BE49-F238E27FC236}">
-                <a16:creationId xmlns:a16="http://schemas.microsoft.com/office/drawing/2014/main" id="{E57CFCE3-8DC4-5AC4-11E4-890A3E8BB3D4}"/>
+                <a16:creationId xmlns:a16="http://schemas.microsoft.com/office/drawing/2014/main" id="{059C28AE-B621-1238-3533-1464E0DA7DFB}"/>
               </a:ext>
             </a:extLst>
           </p:cNvPr>
@@ -4458,7 +4458,7 @@
           <p:cNvPr id="5" name="TextBox 4">
             <a:extLst>
               <a:ext uri="{FF2B5EF4-FFF2-40B4-BE49-F238E27FC236}">
-                <a16:creationId xmlns:a16="http://schemas.microsoft.com/office/drawing/2014/main" id="{198279A2-D49C-138A-C30F-19F5B833ABDF}"/>
+                <a16:creationId xmlns:a16="http://schemas.microsoft.com/office/drawing/2014/main" id="{EFA36FFD-DFDE-3429-729D-3B5A06974208}"/>
               </a:ext>
             </a:extLst>
           </p:cNvPr>
@@ -4496,7 +4496,7 @@
     </p:spTree>
     <p:extLst>
       <p:ext uri="{BB962C8B-B14F-4D97-AF65-F5344CB8AC3E}">
-        <p14:creationId xmlns:p14="http://schemas.microsoft.com/office/powerpoint/2010/main" val="3686949662"/>
+        <p14:creationId xmlns:p14="http://schemas.microsoft.com/office/powerpoint/2010/main" val="2695231002"/>
       </p:ext>
     </p:extLst>
   </p:cSld>
@@ -4536,7 +4536,7 @@
           <p:cNvPr id="2" name="Title 1">
             <a:extLst>
               <a:ext uri="{FF2B5EF4-FFF2-40B4-BE49-F238E27FC236}">
-                <a16:creationId xmlns:a16="http://schemas.microsoft.com/office/drawing/2014/main" id="{E8979E90-AA1B-8B98-1490-D01B316D78F0}"/>
+                <a16:creationId xmlns:a16="http://schemas.microsoft.com/office/drawing/2014/main" id="{03CBCE5F-444B-4FA6-34B5-A542DBB517BB}"/>
               </a:ext>
             </a:extLst>
           </p:cNvPr>
@@ -4571,7 +4571,7 @@
           <p:cNvPr id="3" name="Text Placeholder 2">
             <a:extLst>
               <a:ext uri="{FF2B5EF4-FFF2-40B4-BE49-F238E27FC236}">
-                <a16:creationId xmlns:a16="http://schemas.microsoft.com/office/drawing/2014/main" id="{8963478C-524F-FD63-4BA3-076A10EF662A}"/>
+                <a16:creationId xmlns:a16="http://schemas.microsoft.com/office/drawing/2014/main" id="{BB7C68DC-339A-92F6-21FA-423E450EECE4}"/>
               </a:ext>
             </a:extLst>
           </p:cNvPr>
@@ -4656,7 +4656,7 @@
           <p:cNvPr id="4" name="Rectangle 3">
             <a:extLst>
               <a:ext uri="{FF2B5EF4-FFF2-40B4-BE49-F238E27FC236}">
-                <a16:creationId xmlns:a16="http://schemas.microsoft.com/office/drawing/2014/main" id="{BB2AFBCC-F62E-4AC3-F701-5B984A9FCE4F}"/>
+                <a16:creationId xmlns:a16="http://schemas.microsoft.com/office/drawing/2014/main" id="{25A17713-9740-F11E-6464-DF063591A0B0}"/>
               </a:ext>
             </a:extLst>
           </p:cNvPr>
@@ -4724,7 +4724,7 @@
           <p:cNvPr id="5" name="TextBox 4">
             <a:extLst>
               <a:ext uri="{FF2B5EF4-FFF2-40B4-BE49-F238E27FC236}">
-                <a16:creationId xmlns:a16="http://schemas.microsoft.com/office/drawing/2014/main" id="{74EB2BD2-139A-73F4-7DB4-4F36693F2289}"/>
+                <a16:creationId xmlns:a16="http://schemas.microsoft.com/office/drawing/2014/main" id="{65896522-21B5-7ED5-6B21-E4F5E11AB31F}"/>
               </a:ext>
             </a:extLst>
           </p:cNvPr>
@@ -4762,7 +4762,7 @@
     </p:spTree>
     <p:extLst>
       <p:ext uri="{BB962C8B-B14F-4D97-AF65-F5344CB8AC3E}">
-        <p14:creationId xmlns:p14="http://schemas.microsoft.com/office/powerpoint/2010/main" val="270194855"/>
+        <p14:creationId xmlns:p14="http://schemas.microsoft.com/office/powerpoint/2010/main" val="3982050829"/>
       </p:ext>
     </p:extLst>
   </p:cSld>
@@ -4802,7 +4802,7 @@
           <p:cNvPr id="2" name="Title 1">
             <a:extLst>
               <a:ext uri="{FF2B5EF4-FFF2-40B4-BE49-F238E27FC236}">
-                <a16:creationId xmlns:a16="http://schemas.microsoft.com/office/drawing/2014/main" id="{883F6B90-CF6B-43F9-073C-E0E1A8E483D0}"/>
+                <a16:creationId xmlns:a16="http://schemas.microsoft.com/office/drawing/2014/main" id="{D7F75107-09B7-C9D6-A6AC-D9E870180726}"/>
               </a:ext>
             </a:extLst>
           </p:cNvPr>
@@ -4837,7 +4837,7 @@
           <p:cNvPr id="3" name="Text Placeholder 2">
             <a:extLst>
               <a:ext uri="{FF2B5EF4-FFF2-40B4-BE49-F238E27FC236}">
-                <a16:creationId xmlns:a16="http://schemas.microsoft.com/office/drawing/2014/main" id="{B552CDF0-F060-54D7-CC3D-4EF6DDDF616C}"/>
+                <a16:creationId xmlns:a16="http://schemas.microsoft.com/office/drawing/2014/main" id="{806F7D9D-7C58-67E7-3076-BEF8588AF1CF}"/>
               </a:ext>
             </a:extLst>
           </p:cNvPr>
@@ -4911,7 +4911,7 @@
           <p:cNvPr id="4" name="Rectangle 3">
             <a:extLst>
               <a:ext uri="{FF2B5EF4-FFF2-40B4-BE49-F238E27FC236}">
-                <a16:creationId xmlns:a16="http://schemas.microsoft.com/office/drawing/2014/main" id="{4C5FD2BB-09C5-86C7-9912-84796B1A0883}"/>
+                <a16:creationId xmlns:a16="http://schemas.microsoft.com/office/drawing/2014/main" id="{4352991E-896B-5AD1-C989-9B686C3B3622}"/>
               </a:ext>
             </a:extLst>
           </p:cNvPr>
@@ -4979,7 +4979,7 @@
           <p:cNvPr id="5" name="TextBox 4">
             <a:extLst>
               <a:ext uri="{FF2B5EF4-FFF2-40B4-BE49-F238E27FC236}">
-                <a16:creationId xmlns:a16="http://schemas.microsoft.com/office/drawing/2014/main" id="{78AC8FD1-6B70-21FB-C8C9-01ABE6281059}"/>
+                <a16:creationId xmlns:a16="http://schemas.microsoft.com/office/drawing/2014/main" id="{26C7500A-45DB-A6EB-DBE3-03DDE7FFA65D}"/>
               </a:ext>
             </a:extLst>
           </p:cNvPr>
@@ -5017,7 +5017,7 @@
     </p:spTree>
     <p:extLst>
       <p:ext uri="{BB962C8B-B14F-4D97-AF65-F5344CB8AC3E}">
-        <p14:creationId xmlns:p14="http://schemas.microsoft.com/office/powerpoint/2010/main" val="3181526355"/>
+        <p14:creationId xmlns:p14="http://schemas.microsoft.com/office/powerpoint/2010/main" val="1200219978"/>
       </p:ext>
     </p:extLst>
   </p:cSld>
@@ -5344,6 +5344,6 @@
 
 <file path=docMetadata/LabelInfo.xml><?xml version="1.0" encoding="utf-8"?>
 <clbl:labelList xmlns:clbl="http://schemas.microsoft.com/office/2020/mipLabelMetadata">
-  <clbl:label id="{f42aa342-8706-4288-bd11-ebb85995028c}" enabled="1" method="Standard" siteId="{72f988bf-86f1-41af-91ab-2d7cd011db47}" contentBits="0" removed="0"/>
+  <clbl:label id="{defa4170-0d19-0005-0004-bc88714345d2}" enabled="1" method="Standard" siteId="{855e2d96-2011-4835-a9b0-e77091d62738}" contentBits="0" removed="0"/>
 </clbl:labelList>
 </file>
</xml_diff>